<commit_message>
feat: expand the education corpus to 19 documents
Adds the AI-education guides, teacher digital-literacy standard, evaluation
reform plan, AI-education notice, and regional assessment/teaching-material
documents. Import: 19 documents, 288 chunks, no failures. The deck and the
submission documents now use 25 documents / 380 chunks in total.

The curriculum-plan and curriculum-standard PDFs are scanned images with no
text layer, and this machine has no OCR; they are explicitly left out rather
than shipped as empty or garbled text.

Co-Authored-By: Claude Code <noreply@anthropic.com>
</commit_message>
<xml_diff>
--- a/docs/submission/【教育-重庆邮电大学-赵乙亦-证据工作台】.pptx
+++ b/docs/submission/【教育-重庆邮电大学-赵乙亦-证据工作台】.pptx
@@ -5839,7 +5839,7 @@
                           </a:solidFill>
                           <a:latin typeface="Microsoft YaHei"/>
                         </a:rPr>
-                        <a:t>9</a:t>
+                        <a:t>19</a:t>
                       </a:r>
                     </a:p>
                   </a:txBody>
@@ -5857,7 +5857,7 @@
                           </a:solidFill>
                           <a:latin typeface="Microsoft YaHei"/>
                         </a:rPr>
-                        <a:t>173</a:t>
+                        <a:t>288</a:t>
                       </a:r>
                     </a:p>
                   </a:txBody>
@@ -5913,7 +5913,7 @@
                           </a:solidFill>
                           <a:latin typeface="Microsoft YaHei"/>
                         </a:rPr>
-                        <a:t>15</a:t>
+                        <a:t>25</a:t>
                       </a:r>
                     </a:p>
                   </a:txBody>
@@ -5931,7 +5931,7 @@
                           </a:solidFill>
                           <a:latin typeface="Microsoft YaHei"/>
                         </a:rPr>
-                        <a:t>265</a:t>
+                        <a:t>380</a:t>
                       </a:r>
                     </a:p>
                   </a:txBody>
@@ -6254,7 +6254,7 @@
                 </a:solidFill>
                 <a:latin typeface="Microsoft YaHei"/>
               </a:rPr>
-              <a:t>265 个切片，可定位到章节</a:t>
+              <a:t>380 个切片，可定位到章节</a:t>
             </a:r>
           </a:p>
         </p:txBody>
@@ -6993,7 +6993,7 @@
                 </a:solidFill>
                 <a:latin typeface="Microsoft YaHei"/>
               </a:rPr>
-              <a:t>[图：检索块 265 → 单任务保留证据 → fact claims → 通过校验的引用]</a:t>
+              <a:t>[图：检索块 380 → 单任务保留证据 → fact claims → 通过校验的引用]</a:t>
             </a:r>
           </a:p>
         </p:txBody>

</xml_diff>

<commit_message>
docs: place the real screenshots into the deck
Login, new-task, task graph (cropped to the graph pane so the off-topic
first evidence item does not confuse the page), and the report/conflict
panel. The deck is 19 pages and 712 KB, inside the 50 MB limit.

Co-Authored-By: Claude Code <noreply@anthropic.com>
</commit_message>
<xml_diff>
--- a/docs/submission/【教育-重庆邮电大学-赵乙亦-证据工作台】.pptx
+++ b/docs/submission/【教育-重庆邮电大学-赵乙亦-证据工作台】.pptx
@@ -4897,44 +4897,57 @@
           </a:p>
         </p:txBody>
       </p:sp>
-      <p:sp>
-        <p:nvSpPr>
-          <p:cNvPr id="3" name="TextBox 2"/>
-          <p:cNvSpPr txBox="1"/>
+      <p:pic>
+        <p:nvPicPr>
+          <p:cNvPr id="3" name="Picture 2" descr="login.png"/>
+          <p:cNvPicPr>
+            <a:picLocks noChangeAspect="1"/>
+          </p:cNvPicPr>
           <p:nvPr/>
-        </p:nvSpPr>
-        <p:spPr>
-          <a:xfrm>
-            <a:off x="1097280" y="2011680"/>
-            <a:ext cx="9966960" cy="3291840"/>
+        </p:nvPicPr>
+        <p:blipFill>
+          <a:blip r:embed="rId2"/>
+          <a:stretch>
+            <a:fillRect/>
+          </a:stretch>
+        </p:blipFill>
+        <p:spPr>
+          <a:xfrm>
+            <a:off x="731520" y="1937972"/>
+            <a:ext cx="4206240" cy="3439255"/>
           </a:xfrm>
           <a:prstGeom prst="rect">
             <a:avLst/>
           </a:prstGeom>
-          <a:noFill/>
-        </p:spPr>
-        <p:txBody>
-          <a:bodyPr wrap="square">
-            <a:spAutoFit/>
-          </a:bodyPr>
-          <a:lstStyle/>
-          <a:p>
-            <a:pPr algn="ctr"/>
-            <a:r>
-              <a:rPr sz="2000" b="0">
-                <a:solidFill>
-                  <a:srgbClr val="5B6473"/>
-                </a:solidFill>
-                <a:latin typeface="Microsoft YaHei"/>
-              </a:rPr>
-              <a:t>[截图：登录页 / 工作区与目标输入 / 任务图 + 证据抽屉 / 报告与冲突面板]</a:t>
-            </a:r>
-          </a:p>
-        </p:txBody>
-      </p:sp>
-      <p:sp>
-        <p:nvSpPr>
-          <p:cNvPr id="4" name="TextBox 3"/>
+        </p:spPr>
+      </p:pic>
+      <p:pic>
+        <p:nvPicPr>
+          <p:cNvPr id="4" name="Picture 3" descr="new-task.png"/>
+          <p:cNvPicPr>
+            <a:picLocks noChangeAspect="1"/>
+          </p:cNvPicPr>
+          <p:nvPr/>
+        </p:nvPicPr>
+        <p:blipFill>
+          <a:blip r:embed="rId3"/>
+          <a:stretch>
+            <a:fillRect/>
+          </a:stretch>
+        </p:blipFill>
+        <p:spPr>
+          <a:xfrm>
+            <a:off x="6097801" y="1554480"/>
+            <a:ext cx="4263597" cy="4206240"/>
+          </a:xfrm>
+          <a:prstGeom prst="rect">
+            <a:avLst/>
+          </a:prstGeom>
+        </p:spPr>
+      </p:pic>
+      <p:sp>
+        <p:nvSpPr>
+          <p:cNvPr id="5" name="TextBox 4"/>
           <p:cNvSpPr txBox="1"/>
           <p:nvPr/>
         </p:nvSpPr>
@@ -5072,8 +5085,8 @@
         </p:nvSpPr>
         <p:spPr>
           <a:xfrm>
-            <a:off x="1097280" y="2011680"/>
-            <a:ext cx="9966960" cy="3291840"/>
+            <a:off x="777240" y="4023360"/>
+            <a:ext cx="10607040" cy="1097280"/>
           </a:xfrm>
           <a:prstGeom prst="rect">
             <a:avLst/>
@@ -5086,15 +5099,14 @@
           </a:bodyPr>
           <a:lstStyle/>
           <a:p>
-            <a:pPr algn="ctr"/>
-            <a:r>
-              <a:rPr sz="2000" b="0">
+            <a:r>
+              <a:rPr sz="1500" b="0">
                 <a:solidFill>
                   <a:srgbClr val="5B6473"/>
                 </a:solidFill>
                 <a:latin typeface="Microsoft YaHei"/>
               </a:rPr>
-              <a:t>[截图：报告“结论”与“证据”小节]</a:t>
+              <a:t>运行后，报告在“结论”下逐条列出 [fact] 与依据；点结论可只看它引用的原文（见上一页）。</a:t>
             </a:r>
           </a:p>
         </p:txBody>
@@ -5252,41 +5264,30 @@
           </a:p>
         </p:txBody>
       </p:sp>
-      <p:sp>
-        <p:nvSpPr>
-          <p:cNvPr id="4" name="TextBox 3"/>
-          <p:cNvSpPr txBox="1"/>
+      <p:pic>
+        <p:nvPicPr>
+          <p:cNvPr id="4" name="Picture 3" descr="report-conflicts.png"/>
+          <p:cNvPicPr>
+            <a:picLocks noChangeAspect="1"/>
+          </p:cNvPicPr>
           <p:nvPr/>
-        </p:nvSpPr>
-        <p:spPr>
-          <a:xfrm>
-            <a:off x="1097280" y="2011680"/>
-            <a:ext cx="9966960" cy="3291840"/>
+        </p:nvPicPr>
+        <p:blipFill>
+          <a:blip r:embed="rId2"/>
+          <a:stretch>
+            <a:fillRect/>
+          </a:stretch>
+        </p:blipFill>
+        <p:spPr>
+          <a:xfrm>
+            <a:off x="3965150" y="2743200"/>
+            <a:ext cx="4231218" cy="2834640"/>
           </a:xfrm>
           <a:prstGeom prst="rect">
             <a:avLst/>
           </a:prstGeom>
-          <a:noFill/>
-        </p:spPr>
-        <p:txBody>
-          <a:bodyPr wrap="square">
-            <a:spAutoFit/>
-          </a:bodyPr>
-          <a:lstStyle/>
-          <a:p>
-            <a:pPr algn="ctr"/>
-            <a:r>
-              <a:rPr sz="2000" b="0">
-                <a:solidFill>
-                  <a:srgbClr val="5B6473"/>
-                </a:solidFill>
-                <a:latin typeface="Microsoft YaHei"/>
-              </a:rPr>
-              <a:t>[截图：AI 治理报告 + 冲突候选面板]</a:t>
-            </a:r>
-          </a:p>
-        </p:txBody>
-      </p:sp>
+        </p:spPr>
+      </p:pic>
       <p:sp>
         <p:nvSpPr>
           <p:cNvPr id="5" name="TextBox 4"/>
@@ -6830,41 +6831,30 @@
           </a:p>
         </p:txBody>
       </p:sp>
-      <p:sp>
-        <p:nvSpPr>
-          <p:cNvPr id="3" name="TextBox 2"/>
-          <p:cNvSpPr txBox="1"/>
+      <p:pic>
+        <p:nvPicPr>
+          <p:cNvPr id="3" name="Picture 2" descr="task-graph-crop.png"/>
+          <p:cNvPicPr>
+            <a:picLocks noChangeAspect="1"/>
+          </p:cNvPicPr>
           <p:nvPr/>
-        </p:nvSpPr>
-        <p:spPr>
-          <a:xfrm>
-            <a:off x="1097280" y="2011680"/>
-            <a:ext cx="9966960" cy="3291840"/>
+        </p:nvPicPr>
+        <p:blipFill>
+          <a:blip r:embed="rId2"/>
+          <a:stretch>
+            <a:fillRect/>
+          </a:stretch>
+        </p:blipFill>
+        <p:spPr>
+          <a:xfrm>
+            <a:off x="3863170" y="1463040"/>
+            <a:ext cx="4435179" cy="4846320"/>
           </a:xfrm>
           <a:prstGeom prst="rect">
             <a:avLst/>
           </a:prstGeom>
-          <a:noFill/>
-        </p:spPr>
-        <p:txBody>
-          <a:bodyPr wrap="square">
-            <a:spAutoFit/>
-          </a:bodyPr>
-          <a:lstStyle/>
-          <a:p>
-            <a:pPr algn="ctr"/>
-            <a:r>
-              <a:rPr sz="2000" b="0">
-                <a:solidFill>
-                  <a:srgbClr val="5B6473"/>
-                </a:solidFill>
-                <a:latin typeface="Microsoft YaHei"/>
-              </a:rPr>
-              <a:t>[截图：任务图（两个节点、状态变化）]</a:t>
-            </a:r>
-          </a:p>
-        </p:txBody>
-      </p:sp>
+        </p:spPr>
+      </p:pic>
       <p:sp>
         <p:nvSpPr>
           <p:cNvPr id="4" name="TextBox 3"/>

</xml_diff>

<commit_message>
feat: landing-to-chat flow with a black theme
The app now opens on a Mineradio-style landing page (English wordmark,
click to enter), moves to the glass login, then to a GPT-like composer.
Submitting a goal produces a user message and an agent card whose task
graph, evidence count, conflicts and report appear in place as the run
progresses. Primary buttons are black liquid glass; a stopped run says so
instead of rendering an empty report.

Screenshots in the deck were regenerated from real runs under the new
theme; the deck is 19 pages and validates.

Co-Authored-By: Claude Code <noreply@anthropic.com>
</commit_message>
<xml_diff>
--- a/docs/submission/【教育-重庆邮电大学-赵乙亦-证据工作台】.pptx
+++ b/docs/submission/【教育-重庆邮电大学-赵乙亦-证据工作台】.pptx
@@ -6836,7 +6836,7 @@
       </p:pic>
       <p:pic>
         <p:nvPicPr>
-          <p:cNvPr id="5" name="Image 1" descr="D:\Development\JiuwenSwarm-review\docs\submission\screenshots\new-task.png">    </p:cNvPr>
+          <p:cNvPr id="5" name="Image 1" descr="D:\Development\JiuwenSwarm-review\docs\submission\screenshots\chat-start.png">    </p:cNvPr>
           <p:cNvPicPr>
             <a:picLocks noChangeAspect="1"/>
           </p:cNvPicPr>
@@ -6849,8 +6849,8 @@
         </p:blipFill>
         <p:spPr>
           <a:xfrm>
-            <a:off x="4937760" y="1554480"/>
-            <a:ext cx="4937760" cy="4114800"/>
+            <a:off x="4846320" y="1554480"/>
+            <a:ext cx="5029200" cy="4114800"/>
           </a:xfrm>
           <a:prstGeom prst="rect">
             <a:avLst/>
@@ -12808,12 +12808,12 @@
         </p:nvSpPr>
         <p:spPr>
           <a:xfrm>
-            <a:off x="640080" y="1508760"/>
-            <a:ext cx="4160520" cy="4617720"/>
+            <a:off x="685800" y="1417320"/>
+            <a:ext cx="10835640" cy="3291840"/>
           </a:xfrm>
           <a:prstGeom prst="roundRect">
             <a:avLst>
-              <a:gd name="adj" fmla="val 1758"/>
+              <a:gd name="adj" fmla="val 2222"/>
             </a:avLst>
           </a:prstGeom>
           <a:solidFill>
@@ -12842,8 +12842,8 @@
         </p:blipFill>
         <p:spPr>
           <a:xfrm>
-            <a:off x="777240" y="1645920"/>
-            <a:ext cx="3886200" cy="4343400"/>
+            <a:off x="868680" y="1536192"/>
+            <a:ext cx="10469880" cy="3063240"/>
           </a:xfrm>
           <a:prstGeom prst="rect">
             <a:avLst/>
@@ -12858,7 +12858,7 @@
         </p:nvSpPr>
         <p:spPr>
           <a:xfrm>
-            <a:off x="5074920" y="1737360"/>
+            <a:off x="777240" y="4983480"/>
             <a:ext cx="384048" cy="384048"/>
           </a:xfrm>
           <a:prstGeom prst="ellipse">
@@ -12883,7 +12883,7 @@
         </p:nvSpPr>
         <p:spPr>
           <a:xfrm>
-            <a:off x="5074920" y="1755648"/>
+            <a:off x="777240" y="5001768"/>
             <a:ext cx="384048" cy="347472"/>
           </a:xfrm>
           <a:prstGeom prst="rect">
@@ -12922,24 +12922,24 @@
         </p:nvSpPr>
         <p:spPr>
           <a:xfrm>
-            <a:off x="5577840" y="1737360"/>
-            <a:ext cx="5760720" cy="320040"/>
-          </a:xfrm>
-          <a:prstGeom prst="rect">
-            <a:avLst/>
-          </a:prstGeom>
-          <a:noFill/>
-          <a:ln/>
-        </p:spPr>
-        <p:txBody>
-          <a:bodyPr wrap="square" lIns="0" tIns="0" rIns="0" bIns="0" rtlCol="0" anchor="t"/>
-          <a:lstStyle/>
-          <a:p>
-            <a:pPr indent="0" marL="0">
-              <a:buNone/>
-            </a:pPr>
-            <a:r>
-              <a:rPr lang="en-US" sz="1700" b="1" dirty="0">
+            <a:off x="1280160" y="4965192"/>
+            <a:ext cx="2834640" cy="320040"/>
+          </a:xfrm>
+          <a:prstGeom prst="rect">
+            <a:avLst/>
+          </a:prstGeom>
+          <a:noFill/>
+          <a:ln/>
+        </p:spPr>
+        <p:txBody>
+          <a:bodyPr wrap="square" lIns="0" tIns="0" rIns="0" bIns="0" rtlCol="0" anchor="t"/>
+          <a:lstStyle/>
+          <a:p>
+            <a:pPr indent="0" marL="0">
+              <a:buNone/>
+            </a:pPr>
+            <a:r>
+              <a:rPr lang="en-US" sz="1600" b="1" dirty="0">
                 <a:solidFill>
                   <a:srgbClr val="16211B"/>
                 </a:solidFill>
@@ -12949,7 +12949,7 @@
               </a:rPr>
               <a:t>原生调度</a:t>
             </a:r>
-            <a:endParaRPr lang="en-US" sz="1700" dirty="0"/>
+            <a:endParaRPr lang="en-US" sz="1600" dirty="0"/>
           </a:p>
         </p:txBody>
       </p:sp>
@@ -12961,8 +12961,8 @@
         </p:nvSpPr>
         <p:spPr>
           <a:xfrm>
-            <a:off x="5577840" y="2103120"/>
-            <a:ext cx="5669280" cy="822960"/>
+            <a:off x="1280160" y="5321808"/>
+            <a:ext cx="2926080" cy="914400"/>
           </a:xfrm>
           <a:prstGeom prst="rect">
             <a:avLst/>
@@ -12981,7 +12981,7 @@
               <a:buNone/>
             </a:pPr>
             <a:r>
-              <a:rPr lang="en-US" sz="1200" dirty="0">
+              <a:rPr lang="en-US" sz="1100" dirty="0">
                 <a:solidFill>
                   <a:srgbClr val="5F6B63"/>
                 </a:solidFill>
@@ -12991,7 +12991,7 @@
               </a:rPr>
               <a:t>scheduled 调度器按 assignee 拉起成员</a:t>
             </a:r>
-            <a:endParaRPr lang="en-US" sz="1200" dirty="0"/>
+            <a:endParaRPr lang="en-US" sz="1100" dirty="0"/>
           </a:p>
         </p:txBody>
       </p:sp>
@@ -13003,7 +13003,7 @@
         </p:nvSpPr>
         <p:spPr>
           <a:xfrm>
-            <a:off x="5074920" y="3154680"/>
+            <a:off x="4389120" y="4983480"/>
             <a:ext cx="384048" cy="384048"/>
           </a:xfrm>
           <a:prstGeom prst="ellipse">
@@ -13028,7 +13028,7 @@
         </p:nvSpPr>
         <p:spPr>
           <a:xfrm>
-            <a:off x="5074920" y="3172968"/>
+            <a:off x="4389120" y="5001768"/>
             <a:ext cx="384048" cy="347472"/>
           </a:xfrm>
           <a:prstGeom prst="rect">
@@ -13067,24 +13067,24 @@
         </p:nvSpPr>
         <p:spPr>
           <a:xfrm>
-            <a:off x="5577840" y="3154680"/>
-            <a:ext cx="5760720" cy="320040"/>
-          </a:xfrm>
-          <a:prstGeom prst="rect">
-            <a:avLst/>
-          </a:prstGeom>
-          <a:noFill/>
-          <a:ln/>
-        </p:spPr>
-        <p:txBody>
-          <a:bodyPr wrap="square" lIns="0" tIns="0" rIns="0" bIns="0" rtlCol="0" anchor="t"/>
-          <a:lstStyle/>
-          <a:p>
-            <a:pPr indent="0" marL="0">
-              <a:buNone/>
-            </a:pPr>
-            <a:r>
-              <a:rPr lang="en-US" sz="1700" b="1" dirty="0">
+            <a:off x="4892040" y="4965192"/>
+            <a:ext cx="2834640" cy="320040"/>
+          </a:xfrm>
+          <a:prstGeom prst="rect">
+            <a:avLst/>
+          </a:prstGeom>
+          <a:noFill/>
+          <a:ln/>
+        </p:spPr>
+        <p:txBody>
+          <a:bodyPr wrap="square" lIns="0" tIns="0" rIns="0" bIns="0" rtlCol="0" anchor="t"/>
+          <a:lstStyle/>
+          <a:p>
+            <a:pPr indent="0" marL="0">
+              <a:buNone/>
+            </a:pPr>
+            <a:r>
+              <a:rPr lang="en-US" sz="1600" b="1" dirty="0">
                 <a:solidFill>
                   <a:srgbClr val="16211B"/>
                 </a:solidFill>
@@ -13094,7 +13094,7 @@
               </a:rPr>
               <a:t>结构化回传</a:t>
             </a:r>
-            <a:endParaRPr lang="en-US" sz="1700" dirty="0"/>
+            <a:endParaRPr lang="en-US" sz="1600" dirty="0"/>
           </a:p>
         </p:txBody>
       </p:sp>
@@ -13106,8 +13106,8 @@
         </p:nvSpPr>
         <p:spPr>
           <a:xfrm>
-            <a:off x="5577840" y="3520440"/>
-            <a:ext cx="5669280" cy="822960"/>
+            <a:off x="4892040" y="5321808"/>
+            <a:ext cx="2926080" cy="914400"/>
           </a:xfrm>
           <a:prstGeom prst="rect">
             <a:avLst/>
@@ -13126,7 +13126,7 @@
               <a:buNone/>
             </a:pPr>
             <a:r>
-              <a:rPr lang="en-US" sz="1200" dirty="0">
+              <a:rPr lang="en-US" sz="1100" dirty="0">
                 <a:solidFill>
                   <a:srgbClr val="5F6B63"/>
                 </a:solidFill>
@@ -13136,7 +13136,7 @@
               </a:rPr>
               <a:t>成员通过受校验的 submit 工具提交 claims / evidence</a:t>
             </a:r>
-            <a:endParaRPr lang="en-US" sz="1200" dirty="0"/>
+            <a:endParaRPr lang="en-US" sz="1100" dirty="0"/>
           </a:p>
         </p:txBody>
       </p:sp>
@@ -13148,7 +13148,7 @@
         </p:nvSpPr>
         <p:spPr>
           <a:xfrm>
-            <a:off x="5074920" y="4572000"/>
+            <a:off x="8001000" y="4983480"/>
             <a:ext cx="384048" cy="384048"/>
           </a:xfrm>
           <a:prstGeom prst="ellipse">
@@ -13173,7 +13173,7 @@
         </p:nvSpPr>
         <p:spPr>
           <a:xfrm>
-            <a:off x="5074920" y="4590288"/>
+            <a:off x="8001000" y="5001768"/>
             <a:ext cx="384048" cy="347472"/>
           </a:xfrm>
           <a:prstGeom prst="rect">
@@ -13212,24 +13212,24 @@
         </p:nvSpPr>
         <p:spPr>
           <a:xfrm>
-            <a:off x="5577840" y="4572000"/>
-            <a:ext cx="5760720" cy="320040"/>
-          </a:xfrm>
-          <a:prstGeom prst="rect">
-            <a:avLst/>
-          </a:prstGeom>
-          <a:noFill/>
-          <a:ln/>
-        </p:spPr>
-        <p:txBody>
-          <a:bodyPr wrap="square" lIns="0" tIns="0" rIns="0" bIns="0" rtlCol="0" anchor="t"/>
-          <a:lstStyle/>
-          <a:p>
-            <a:pPr indent="0" marL="0">
-              <a:buNone/>
-            </a:pPr>
-            <a:r>
-              <a:rPr lang="en-US" sz="1700" b="1" dirty="0">
+            <a:off x="8503920" y="4965192"/>
+            <a:ext cx="2834640" cy="320040"/>
+          </a:xfrm>
+          <a:prstGeom prst="rect">
+            <a:avLst/>
+          </a:prstGeom>
+          <a:noFill/>
+          <a:ln/>
+        </p:spPr>
+        <p:txBody>
+          <a:bodyPr wrap="square" lIns="0" tIns="0" rIns="0" bIns="0" rtlCol="0" anchor="t"/>
+          <a:lstStyle/>
+          <a:p>
+            <a:pPr indent="0" marL="0">
+              <a:buNone/>
+            </a:pPr>
+            <a:r>
+              <a:rPr lang="en-US" sz="1600" b="1" dirty="0">
                 <a:solidFill>
                   <a:srgbClr val="16211B"/>
                 </a:solidFill>
@@ -13239,7 +13239,7 @@
               </a:rPr>
               <a:t>可审计</a:t>
             </a:r>
-            <a:endParaRPr lang="en-US" sz="1700" dirty="0"/>
+            <a:endParaRPr lang="en-US" sz="1600" dirty="0"/>
           </a:p>
         </p:txBody>
       </p:sp>
@@ -13251,8 +13251,8 @@
         </p:nvSpPr>
         <p:spPr>
           <a:xfrm>
-            <a:off x="5577840" y="4937760"/>
-            <a:ext cx="5669280" cy="822960"/>
+            <a:off x="8503920" y="5321808"/>
+            <a:ext cx="2926080" cy="914400"/>
           </a:xfrm>
           <a:prstGeom prst="rect">
             <a:avLst/>
@@ -13271,7 +13271,7 @@
               <a:buNone/>
             </a:pPr>
             <a:r>
-              <a:rPr lang="en-US" sz="1200" dirty="0">
+              <a:rPr lang="en-US" sz="1100" dirty="0">
                 <a:solidFill>
                   <a:srgbClr val="5F6B63"/>
                 </a:solidFill>
@@ -13281,7 +13281,7 @@
               </a:rPr>
               <a:t>每个 result 绑定 execution，过期执行不能覆盖</a:t>
             </a:r>
-            <a:endParaRPr lang="en-US" sz="1200" dirty="0"/>
+            <a:endParaRPr lang="en-US" sz="1100" dirty="0"/>
           </a:p>
         </p:txBody>
       </p:sp>

</xml_diff>

<commit_message>
feat: move to the personal environment and new domain
The trial environment exhausted its 3,000 credits and was isolated. A new
personal environment (one month) now runs the same image; deploy 002
succeeded after one transient registry error. All submission links and the
deck point at the new domain.

Also hides the docked composer after submit and reveals it near the bottom
edge, with a small 继续提问 handle for touch clients.

Co-Authored-By: Claude Code <noreply@anthropic.com>
</commit_message>
<xml_diff>
--- a/docs/submission/【教育-重庆邮电大学-赵乙亦-证据工作台】.pptx
+++ b/docs/submission/【教育-重庆邮电大学-赵乙亦-证据工作台】.pptx
@@ -2956,7 +2956,7 @@
                 <a:ea typeface="Microsoft YaHei" pitchFamily="34" charset="-122"/>
                 <a:cs typeface="Microsoft YaHei" pitchFamily="34" charset="-120"/>
               </a:rPr>
-              <a:t>https://workbench-334475-5-1515867239.sh.run.tcloudbase.com</a:t>
+              <a:t>https://workbench-335317-9-1515867239.sh.run.tcloudbase.com</a:t>
             </a:r>
             <a:endParaRPr lang="en-US" sz="1100" dirty="0"/>
           </a:p>
@@ -8410,7 +8410,7 @@
                 <a:ea typeface="Microsoft YaHei" pitchFamily="34" charset="-122"/>
                 <a:cs typeface="Microsoft YaHei" pitchFamily="34" charset="-120"/>
               </a:rPr>
-              <a:t>https://workbench-334475-5-1515867239.sh.run.tcloudbase.com</a:t>
+              <a:t>https://workbench-335317-9-1515867239.sh.run.tcloudbase.com</a:t>
             </a:r>
             <a:endParaRPr lang="en-US" sz="1300" dirty="0"/>
           </a:p>

</xml_diff>

<commit_message>
chore: finalise the nineteen-slide deck
WPS released the file, so the updated deck with the real run numbers and the
black-theme screenshots now replaces the old copy. Validation passes and the
exported slides were checked page by page.

Co-Authored-By: Claude Code <noreply@anthropic.com>
</commit_message>
<xml_diff>
--- a/docs/submission/【教育-重庆邮电大学-赵乙亦-证据工作台】.pptx
+++ b/docs/submission/【教育-重庆邮电大学-赵乙亦-证据工作台】.pptx
@@ -14133,7 +14133,7 @@
                 <a:ea typeface="Microsoft YaHei" pitchFamily="34" charset="-122"/>
                 <a:cs typeface="Microsoft YaHei" pitchFamily="34" charset="-120"/>
               </a:rPr>
-              <a:t>39</a:t>
+              <a:t>40</a:t>
             </a:r>
             <a:endParaRPr lang="en-US" sz="3800" dirty="0"/>
           </a:p>
@@ -14211,7 +14211,7 @@
                 <a:ea typeface="Microsoft YaHei" pitchFamily="34" charset="-122"/>
                 <a:cs typeface="Microsoft YaHei" pitchFamily="34" charset="-120"/>
               </a:rPr>
-              <a:t>630 项断言 · 0 失败</a:t>
+              <a:t>645 项断言 · 0 失败</a:t>
             </a:r>
             <a:endParaRPr lang="en-US" sz="1100" dirty="0"/>
           </a:p>
@@ -14277,7 +14277,7 @@
                 <a:ea typeface="Microsoft YaHei" pitchFamily="34" charset="-122"/>
                 <a:cs typeface="Microsoft YaHei" pitchFamily="34" charset="-120"/>
               </a:rPr>
-              <a:t>57 KB</a:t>
+              <a:t>55 KB</a:t>
             </a:r>
             <a:endParaRPr lang="en-US" sz="3800" dirty="0"/>
           </a:p>
@@ -14499,7 +14499,7 @@
                 <a:ea typeface="Microsoft YaHei" pitchFamily="34" charset="-122"/>
                 <a:cs typeface="Microsoft YaHei" pitchFamily="34" charset="-120"/>
               </a:rPr>
-              <a:t>AI 治理 59 KB · 教育 57 KB</a:t>
+              <a:t>AI 治理 59 KB · 教育 55 KB</a:t>
             </a:r>
             <a:endParaRPr lang="en-US" sz="1100" dirty="0"/>
           </a:p>

</xml_diff>